<commit_message>
Remove SOURCE ACCOUNT tags from the Personal AI Assistant deck
Author decision (14 October 2026): the tag is distracting. Removes all
18 badges (rounded rectangle plus text box) on slides 2-6, 8, 9, 11-13,
19, 22 and 25, as already done in the Prosperity Economics deck.

- Slide 3 legend: untagged content presents the primary texts; the
  THIS NOTE'S PROPOSAL and RESEARCH tags remain.
- Slide 1 and 3 speaker notes updated to match.
- Studies/index.html: finalizer cache-bust refresh.
- PENDING.md: ST-DECK-01 closed.

Co-Authored-By: Claude Opus 5.5 <noreply@anthropic.com>
</commit_message>
<xml_diff>
--- a/Studies/Artificial-Intelligence-And-Coexistence/The-Personal-AI-Assistant-Coexistential-Perspective.pptx
+++ b/Studies/Artificial-Intelligence-And-Coexistence/The-Personal-AI-Assistant-Coexistential-Perspective.pptx
@@ -544,7 +544,7 @@
           <a:p/>
           <a:p>
             <a:r>
-              <a:t>Two kinds of material run through the deck and are kept apart on every slide. A chip marked Source account shows what the primary texts teach; page locators to MVD, JV and KD appear in the footer. A chip marked This note's proposal shows the AI analogy, the architecture and the applications, which are the note's own contemporary development of that account. A third chip, Research, marks bounded findings from current AI studies. None of the proposals has yet been implemented or validated as a system.</a:t>
+              <a:t>Two kinds of material run through the deck and are kept apart on every slide. Material without a chip presents what the primary texts teach; page locators to MVD, JV and KD appear in the footer. A chip marked This note's proposal shows the AI analogy, the architecture and the applications, which are the note's own contemporary development of that account. A third chip, Research, marks bounded findings from current AI studies. None of the proposals has yet been implemented or validated as a system.</a:t>
             </a:r>
           </a:p>
         </p:txBody>
@@ -2480,7 +2480,7 @@
           <a:p/>
           <a:p>
             <a:r>
-              <a:t>The chips explained here recur on every slide. Keep the distinction in view: the darshan supplies the account of jeevan, delusion and humane conduct; the analogy with AI is the note's own.</a:t>
+              <a:t>The chips explained here recur throughout the deck; content without a chip is the darshan's own account. Keep the distinction in view: the darshan supplies the account of jeevan, delusion and humane conduct; the analogy with AI is the note's own.</a:t>
             </a:r>
           </a:p>
         </p:txBody>
@@ -8347,79 +8347,6 @@
       </p:sp>
       <p:sp>
         <p:nvSpPr>
-          <p:cNvPr id="10" name="Rounded Rectangle 9"/>
-          <p:cNvSpPr/>
-          <p:nvPr/>
-        </p:nvSpPr>
-        <p:spPr>
-          <a:xfrm>
-            <a:off x="4059935" y="1737360"/>
-            <a:ext cx="1024128" cy="182880"/>
-          </a:xfrm>
-          <a:prstGeom prst="roundRect">
-            <a:avLst>
-              <a:gd name="adj" fmla="val 50000"/>
-            </a:avLst>
-          </a:prstGeom>
-          <a:solidFill>
-            <a:srgbClr val="1E2447"/>
-          </a:solidFill>
-          <a:ln>
-            <a:noFill/>
-          </a:ln>
-        </p:spPr>
-        <p:txBody>
-          <a:bodyPr rtlCol="0" anchor="ctr"/>
-          <a:lstStyle/>
-          <a:p>
-            <a:pPr algn="ctr"/>
-          </a:p>
-        </p:txBody>
-      </p:sp>
-      <p:sp>
-        <p:nvSpPr>
-          <p:cNvPr id="11" name="TextBox 10"/>
-          <p:cNvSpPr txBox="1"/>
-          <p:nvPr/>
-        </p:nvSpPr>
-        <p:spPr>
-          <a:xfrm>
-            <a:off x="4059935" y="1737360"/>
-            <a:ext cx="1024128" cy="182880"/>
-          </a:xfrm>
-          <a:prstGeom prst="rect">
-            <a:avLst/>
-          </a:prstGeom>
-          <a:noFill/>
-        </p:spPr>
-        <p:txBody>
-          <a:bodyPr wrap="square" lIns="0" rIns="0" tIns="0" bIns="0" anchor="ctr">
-            <a:noAutofit/>
-          </a:bodyPr>
-          <a:lstStyle/>
-          <a:p>
-            <a:pPr algn="ctr">
-              <a:spcBef>
-                <a:spcPts val="0"/>
-              </a:spcBef>
-              <a:spcAft>
-                <a:spcPts val="0"/>
-              </a:spcAft>
-            </a:pPr>
-            <a:r>
-              <a:rPr sz="750" b="1" i="0">
-                <a:solidFill>
-                  <a:srgbClr val="FFFFFF"/>
-                </a:solidFill>
-                <a:latin typeface="Calibri"/>
-              </a:rPr>
-              <a:t>SOURCE ACCOUNT</a:t>
-            </a:r>
-          </a:p>
-        </p:txBody>
-      </p:sp>
-      <p:sp>
-        <p:nvSpPr>
           <p:cNvPr id="12" name="TextBox 11"/>
           <p:cNvSpPr txBox="1"/>
           <p:nvPr/>
@@ -8824,79 +8751,6 @@
       </p:sp>
       <p:sp>
         <p:nvSpPr>
-          <p:cNvPr id="22" name="Rounded Rectangle 21"/>
-          <p:cNvSpPr/>
-          <p:nvPr/>
-        </p:nvSpPr>
-        <p:spPr>
-          <a:xfrm>
-            <a:off x="7351775" y="1737360"/>
-            <a:ext cx="1024128" cy="182880"/>
-          </a:xfrm>
-          <a:prstGeom prst="roundRect">
-            <a:avLst>
-              <a:gd name="adj" fmla="val 50000"/>
-            </a:avLst>
-          </a:prstGeom>
-          <a:solidFill>
-            <a:srgbClr val="1E2447"/>
-          </a:solidFill>
-          <a:ln>
-            <a:noFill/>
-          </a:ln>
-        </p:spPr>
-        <p:txBody>
-          <a:bodyPr rtlCol="0" anchor="ctr"/>
-          <a:lstStyle/>
-          <a:p>
-            <a:pPr algn="ctr"/>
-          </a:p>
-        </p:txBody>
-      </p:sp>
-      <p:sp>
-        <p:nvSpPr>
-          <p:cNvPr id="23" name="TextBox 22"/>
-          <p:cNvSpPr txBox="1"/>
-          <p:nvPr/>
-        </p:nvSpPr>
-        <p:spPr>
-          <a:xfrm>
-            <a:off x="7351775" y="1737360"/>
-            <a:ext cx="1024128" cy="182880"/>
-          </a:xfrm>
-          <a:prstGeom prst="rect">
-            <a:avLst/>
-          </a:prstGeom>
-          <a:noFill/>
-        </p:spPr>
-        <p:txBody>
-          <a:bodyPr wrap="square" lIns="0" rIns="0" tIns="0" bIns="0" anchor="ctr">
-            <a:noAutofit/>
-          </a:bodyPr>
-          <a:lstStyle/>
-          <a:p>
-            <a:pPr algn="ctr">
-              <a:spcBef>
-                <a:spcPts val="0"/>
-              </a:spcBef>
-              <a:spcAft>
-                <a:spcPts val="0"/>
-              </a:spcAft>
-            </a:pPr>
-            <a:r>
-              <a:rPr sz="750" b="1" i="0">
-                <a:solidFill>
-                  <a:srgbClr val="FFFFFF"/>
-                </a:solidFill>
-                <a:latin typeface="Calibri"/>
-              </a:rPr>
-              <a:t>SOURCE ACCOUNT</a:t>
-            </a:r>
-          </a:p>
-        </p:txBody>
-      </p:sp>
-      <p:sp>
-        <p:nvSpPr>
           <p:cNvPr id="24" name="TextBox 23"/>
           <p:cNvSpPr txBox="1"/>
           <p:nvPr/>
@@ -9007,79 +8861,6 @@
           <a:lstStyle/>
           <a:p>
             <a:pPr algn="ctr"/>
-          </a:p>
-        </p:txBody>
-      </p:sp>
-      <p:sp>
-        <p:nvSpPr>
-          <p:cNvPr id="27" name="Rounded Rectangle 26"/>
-          <p:cNvSpPr/>
-          <p:nvPr/>
-        </p:nvSpPr>
-        <p:spPr>
-          <a:xfrm>
-            <a:off x="7351775" y="2990088"/>
-            <a:ext cx="1024128" cy="182880"/>
-          </a:xfrm>
-          <a:prstGeom prst="roundRect">
-            <a:avLst>
-              <a:gd name="adj" fmla="val 50000"/>
-            </a:avLst>
-          </a:prstGeom>
-          <a:solidFill>
-            <a:srgbClr val="1E2447"/>
-          </a:solidFill>
-          <a:ln>
-            <a:noFill/>
-          </a:ln>
-        </p:spPr>
-        <p:txBody>
-          <a:bodyPr rtlCol="0" anchor="ctr"/>
-          <a:lstStyle/>
-          <a:p>
-            <a:pPr algn="ctr"/>
-          </a:p>
-        </p:txBody>
-      </p:sp>
-      <p:sp>
-        <p:nvSpPr>
-          <p:cNvPr id="28" name="TextBox 27"/>
-          <p:cNvSpPr txBox="1"/>
-          <p:nvPr/>
-        </p:nvSpPr>
-        <p:spPr>
-          <a:xfrm>
-            <a:off x="7351775" y="2990088"/>
-            <a:ext cx="1024128" cy="182880"/>
-          </a:xfrm>
-          <a:prstGeom prst="rect">
-            <a:avLst/>
-          </a:prstGeom>
-          <a:noFill/>
-        </p:spPr>
-        <p:txBody>
-          <a:bodyPr wrap="square" lIns="0" rIns="0" tIns="0" bIns="0" anchor="ctr">
-            <a:noAutofit/>
-          </a:bodyPr>
-          <a:lstStyle/>
-          <a:p>
-            <a:pPr algn="ctr">
-              <a:spcBef>
-                <a:spcPts val="0"/>
-              </a:spcBef>
-              <a:spcAft>
-                <a:spcPts val="0"/>
-              </a:spcAft>
-            </a:pPr>
-            <a:r>
-              <a:rPr sz="750" b="1" i="0">
-                <a:solidFill>
-                  <a:srgbClr val="FFFFFF"/>
-                </a:solidFill>
-                <a:latin typeface="Calibri"/>
-              </a:rPr>
-              <a:t>SOURCE ACCOUNT</a:t>
-            </a:r>
           </a:p>
         </p:txBody>
       </p:sp>
@@ -9450,79 +9231,6 @@
       </p:sp>
       <p:sp>
         <p:nvSpPr>
-          <p:cNvPr id="8" name="Rounded Rectangle 7"/>
-          <p:cNvSpPr/>
-          <p:nvPr/>
-        </p:nvSpPr>
-        <p:spPr>
-          <a:xfrm>
-            <a:off x="7479792" y="1051560"/>
-            <a:ext cx="1024128" cy="182880"/>
-          </a:xfrm>
-          <a:prstGeom prst="roundRect">
-            <a:avLst>
-              <a:gd name="adj" fmla="val 50000"/>
-            </a:avLst>
-          </a:prstGeom>
-          <a:solidFill>
-            <a:srgbClr val="1E2447"/>
-          </a:solidFill>
-          <a:ln>
-            <a:noFill/>
-          </a:ln>
-        </p:spPr>
-        <p:txBody>
-          <a:bodyPr rtlCol="0" anchor="ctr"/>
-          <a:lstStyle/>
-          <a:p>
-            <a:pPr algn="ctr"/>
-          </a:p>
-        </p:txBody>
-      </p:sp>
-      <p:sp>
-        <p:nvSpPr>
-          <p:cNvPr id="9" name="TextBox 8"/>
-          <p:cNvSpPr txBox="1"/>
-          <p:nvPr/>
-        </p:nvSpPr>
-        <p:spPr>
-          <a:xfrm>
-            <a:off x="7479792" y="1051560"/>
-            <a:ext cx="1024128" cy="182880"/>
-          </a:xfrm>
-          <a:prstGeom prst="rect">
-            <a:avLst/>
-          </a:prstGeom>
-          <a:noFill/>
-        </p:spPr>
-        <p:txBody>
-          <a:bodyPr wrap="square" lIns="0" rIns="0" tIns="0" bIns="0" anchor="ctr">
-            <a:noAutofit/>
-          </a:bodyPr>
-          <a:lstStyle/>
-          <a:p>
-            <a:pPr algn="ctr">
-              <a:spcBef>
-                <a:spcPts val="0"/>
-              </a:spcBef>
-              <a:spcAft>
-                <a:spcPts val="0"/>
-              </a:spcAft>
-            </a:pPr>
-            <a:r>
-              <a:rPr sz="750" b="1" i="0">
-                <a:solidFill>
-                  <a:srgbClr val="FFFFFF"/>
-                </a:solidFill>
-                <a:latin typeface="Calibri"/>
-              </a:rPr>
-              <a:t>SOURCE ACCOUNT</a:t>
-            </a:r>
-          </a:p>
-        </p:txBody>
-      </p:sp>
-      <p:sp>
-        <p:nvSpPr>
           <p:cNvPr id="10" name="Rounded Rectangle 9"/>
           <p:cNvSpPr/>
           <p:nvPr/>
@@ -11732,79 +11440,6 @@
       </p:sp>
       <p:sp>
         <p:nvSpPr>
-          <p:cNvPr id="31" name="Rounded Rectangle 30"/>
-          <p:cNvSpPr/>
-          <p:nvPr/>
-        </p:nvSpPr>
-        <p:spPr>
-          <a:xfrm>
-            <a:off x="7351775" y="2606040"/>
-            <a:ext cx="1024128" cy="182880"/>
-          </a:xfrm>
-          <a:prstGeom prst="roundRect">
-            <a:avLst>
-              <a:gd name="adj" fmla="val 50000"/>
-            </a:avLst>
-          </a:prstGeom>
-          <a:solidFill>
-            <a:srgbClr val="1E2447"/>
-          </a:solidFill>
-          <a:ln>
-            <a:noFill/>
-          </a:ln>
-        </p:spPr>
-        <p:txBody>
-          <a:bodyPr rtlCol="0" anchor="ctr"/>
-          <a:lstStyle/>
-          <a:p>
-            <a:pPr algn="ctr"/>
-          </a:p>
-        </p:txBody>
-      </p:sp>
-      <p:sp>
-        <p:nvSpPr>
-          <p:cNvPr id="32" name="TextBox 31"/>
-          <p:cNvSpPr txBox="1"/>
-          <p:nvPr/>
-        </p:nvSpPr>
-        <p:spPr>
-          <a:xfrm>
-            <a:off x="7351775" y="2606040"/>
-            <a:ext cx="1024128" cy="182880"/>
-          </a:xfrm>
-          <a:prstGeom prst="rect">
-            <a:avLst/>
-          </a:prstGeom>
-          <a:noFill/>
-        </p:spPr>
-        <p:txBody>
-          <a:bodyPr wrap="square" lIns="0" rIns="0" tIns="0" bIns="0" anchor="ctr">
-            <a:noAutofit/>
-          </a:bodyPr>
-          <a:lstStyle/>
-          <a:p>
-            <a:pPr algn="ctr">
-              <a:spcBef>
-                <a:spcPts val="0"/>
-              </a:spcBef>
-              <a:spcAft>
-                <a:spcPts val="0"/>
-              </a:spcAft>
-            </a:pPr>
-            <a:r>
-              <a:rPr sz="750" b="1" i="0">
-                <a:solidFill>
-                  <a:srgbClr val="FFFFFF"/>
-                </a:solidFill>
-                <a:latin typeface="Calibri"/>
-              </a:rPr>
-              <a:t>SOURCE ACCOUNT</a:t>
-            </a:r>
-          </a:p>
-        </p:txBody>
-      </p:sp>
-      <p:sp>
-        <p:nvSpPr>
           <p:cNvPr id="33" name="TextBox 32"/>
           <p:cNvSpPr txBox="1"/>
           <p:nvPr/>
@@ -18220,79 +17855,6 @@
       </p:sp>
       <p:sp>
         <p:nvSpPr>
-          <p:cNvPr id="33" name="Rounded Rectangle 32"/>
-          <p:cNvSpPr/>
-          <p:nvPr/>
-        </p:nvSpPr>
-        <p:spPr>
-          <a:xfrm>
-            <a:off x="7351775" y="2944368"/>
-            <a:ext cx="1024128" cy="182880"/>
-          </a:xfrm>
-          <a:prstGeom prst="roundRect">
-            <a:avLst>
-              <a:gd name="adj" fmla="val 50000"/>
-            </a:avLst>
-          </a:prstGeom>
-          <a:solidFill>
-            <a:srgbClr val="1E2447"/>
-          </a:solidFill>
-          <a:ln>
-            <a:noFill/>
-          </a:ln>
-        </p:spPr>
-        <p:txBody>
-          <a:bodyPr rtlCol="0" anchor="ctr"/>
-          <a:lstStyle/>
-          <a:p>
-            <a:pPr algn="ctr"/>
-          </a:p>
-        </p:txBody>
-      </p:sp>
-      <p:sp>
-        <p:nvSpPr>
-          <p:cNvPr id="34" name="TextBox 33"/>
-          <p:cNvSpPr txBox="1"/>
-          <p:nvPr/>
-        </p:nvSpPr>
-        <p:spPr>
-          <a:xfrm>
-            <a:off x="7351775" y="2944368"/>
-            <a:ext cx="1024128" cy="182880"/>
-          </a:xfrm>
-          <a:prstGeom prst="rect">
-            <a:avLst/>
-          </a:prstGeom>
-          <a:noFill/>
-        </p:spPr>
-        <p:txBody>
-          <a:bodyPr wrap="square" lIns="0" rIns="0" tIns="0" bIns="0" anchor="ctr">
-            <a:noAutofit/>
-          </a:bodyPr>
-          <a:lstStyle/>
-          <a:p>
-            <a:pPr algn="ctr">
-              <a:spcBef>
-                <a:spcPts val="0"/>
-              </a:spcBef>
-              <a:spcAft>
-                <a:spcPts val="0"/>
-              </a:spcAft>
-            </a:pPr>
-            <a:r>
-              <a:rPr sz="750" b="1" i="0">
-                <a:solidFill>
-                  <a:srgbClr val="FFFFFF"/>
-                </a:solidFill>
-                <a:latin typeface="Calibri"/>
-              </a:rPr>
-              <a:t>SOURCE ACCOUNT</a:t>
-            </a:r>
-          </a:p>
-        </p:txBody>
-      </p:sp>
-      <p:sp>
-        <p:nvSpPr>
           <p:cNvPr id="35" name="TextBox 34"/>
           <p:cNvSpPr txBox="1"/>
           <p:nvPr/>
@@ -19348,79 +18910,6 @@
       </p:sp>
       <p:sp>
         <p:nvSpPr>
-          <p:cNvPr id="27" name="Rounded Rectangle 26"/>
-          <p:cNvSpPr/>
-          <p:nvPr/>
-        </p:nvSpPr>
-        <p:spPr>
-          <a:xfrm>
-            <a:off x="7351775" y="2880360"/>
-            <a:ext cx="1024128" cy="182880"/>
-          </a:xfrm>
-          <a:prstGeom prst="roundRect">
-            <a:avLst>
-              <a:gd name="adj" fmla="val 50000"/>
-            </a:avLst>
-          </a:prstGeom>
-          <a:solidFill>
-            <a:srgbClr val="1E2447"/>
-          </a:solidFill>
-          <a:ln>
-            <a:noFill/>
-          </a:ln>
-        </p:spPr>
-        <p:txBody>
-          <a:bodyPr rtlCol="0" anchor="ctr"/>
-          <a:lstStyle/>
-          <a:p>
-            <a:pPr algn="ctr"/>
-          </a:p>
-        </p:txBody>
-      </p:sp>
-      <p:sp>
-        <p:nvSpPr>
-          <p:cNvPr id="28" name="TextBox 27"/>
-          <p:cNvSpPr txBox="1"/>
-          <p:nvPr/>
-        </p:nvSpPr>
-        <p:spPr>
-          <a:xfrm>
-            <a:off x="7351775" y="2880360"/>
-            <a:ext cx="1024128" cy="182880"/>
-          </a:xfrm>
-          <a:prstGeom prst="rect">
-            <a:avLst/>
-          </a:prstGeom>
-          <a:noFill/>
-        </p:spPr>
-        <p:txBody>
-          <a:bodyPr wrap="square" lIns="0" rIns="0" tIns="0" bIns="0" anchor="ctr">
-            <a:noAutofit/>
-          </a:bodyPr>
-          <a:lstStyle/>
-          <a:p>
-            <a:pPr algn="ctr">
-              <a:spcBef>
-                <a:spcPts val="0"/>
-              </a:spcBef>
-              <a:spcAft>
-                <a:spcPts val="0"/>
-              </a:spcAft>
-            </a:pPr>
-            <a:r>
-              <a:rPr sz="750" b="1" i="0">
-                <a:solidFill>
-                  <a:srgbClr val="FFFFFF"/>
-                </a:solidFill>
-                <a:latin typeface="Calibri"/>
-              </a:rPr>
-              <a:t>SOURCE ACCOUNT</a:t>
-            </a:r>
-          </a:p>
-        </p:txBody>
-      </p:sp>
-      <p:sp>
-        <p:nvSpPr>
           <p:cNvPr id="29" name="TextBox 28"/>
           <p:cNvSpPr txBox="1"/>
           <p:nvPr/>
@@ -23172,79 +22661,6 @@
       </p:sp>
       <p:sp>
         <p:nvSpPr>
-          <p:cNvPr id="33" name="Rounded Rectangle 32"/>
-          <p:cNvSpPr/>
-          <p:nvPr/>
-        </p:nvSpPr>
-        <p:spPr>
-          <a:xfrm>
-            <a:off x="7351775" y="2029967"/>
-            <a:ext cx="1024128" cy="182880"/>
-          </a:xfrm>
-          <a:prstGeom prst="roundRect">
-            <a:avLst>
-              <a:gd name="adj" fmla="val 50000"/>
-            </a:avLst>
-          </a:prstGeom>
-          <a:solidFill>
-            <a:srgbClr val="1E2447"/>
-          </a:solidFill>
-          <a:ln>
-            <a:noFill/>
-          </a:ln>
-        </p:spPr>
-        <p:txBody>
-          <a:bodyPr rtlCol="0" anchor="ctr"/>
-          <a:lstStyle/>
-          <a:p>
-            <a:pPr algn="ctr"/>
-          </a:p>
-        </p:txBody>
-      </p:sp>
-      <p:sp>
-        <p:nvSpPr>
-          <p:cNvPr id="34" name="TextBox 33"/>
-          <p:cNvSpPr txBox="1"/>
-          <p:nvPr/>
-        </p:nvSpPr>
-        <p:spPr>
-          <a:xfrm>
-            <a:off x="7351775" y="2029967"/>
-            <a:ext cx="1024128" cy="182880"/>
-          </a:xfrm>
-          <a:prstGeom prst="rect">
-            <a:avLst/>
-          </a:prstGeom>
-          <a:noFill/>
-        </p:spPr>
-        <p:txBody>
-          <a:bodyPr wrap="square" lIns="0" rIns="0" tIns="0" bIns="0" anchor="ctr">
-            <a:noAutofit/>
-          </a:bodyPr>
-          <a:lstStyle/>
-          <a:p>
-            <a:pPr algn="ctr">
-              <a:spcBef>
-                <a:spcPts val="0"/>
-              </a:spcBef>
-              <a:spcAft>
-                <a:spcPts val="0"/>
-              </a:spcAft>
-            </a:pPr>
-            <a:r>
-              <a:rPr sz="750" b="1" i="0">
-                <a:solidFill>
-                  <a:srgbClr val="FFFFFF"/>
-                </a:solidFill>
-                <a:latin typeface="Calibri"/>
-              </a:rPr>
-              <a:t>SOURCE ACCOUNT</a:t>
-            </a:r>
-          </a:p>
-        </p:txBody>
-      </p:sp>
-      <p:sp>
-        <p:nvSpPr>
           <p:cNvPr id="35" name="TextBox 34"/>
           <p:cNvSpPr txBox="1"/>
           <p:nvPr/>
@@ -25597,79 +25013,6 @@
       </p:sp>
       <p:sp>
         <p:nvSpPr>
-          <p:cNvPr id="8" name="Rounded Rectangle 7"/>
-          <p:cNvSpPr/>
-          <p:nvPr/>
-        </p:nvSpPr>
-        <p:spPr>
-          <a:xfrm>
-            <a:off x="1856231" y="1042415"/>
-            <a:ext cx="1024128" cy="182880"/>
-          </a:xfrm>
-          <a:prstGeom prst="roundRect">
-            <a:avLst>
-              <a:gd name="adj" fmla="val 50000"/>
-            </a:avLst>
-          </a:prstGeom>
-          <a:solidFill>
-            <a:srgbClr val="1E2447"/>
-          </a:solidFill>
-          <a:ln>
-            <a:noFill/>
-          </a:ln>
-        </p:spPr>
-        <p:txBody>
-          <a:bodyPr rtlCol="0" anchor="ctr"/>
-          <a:lstStyle/>
-          <a:p>
-            <a:pPr algn="ctr"/>
-          </a:p>
-        </p:txBody>
-      </p:sp>
-      <p:sp>
-        <p:nvSpPr>
-          <p:cNvPr id="9" name="TextBox 8"/>
-          <p:cNvSpPr txBox="1"/>
-          <p:nvPr/>
-        </p:nvSpPr>
-        <p:spPr>
-          <a:xfrm>
-            <a:off x="1856231" y="1042415"/>
-            <a:ext cx="1024128" cy="182880"/>
-          </a:xfrm>
-          <a:prstGeom prst="rect">
-            <a:avLst/>
-          </a:prstGeom>
-          <a:noFill/>
-        </p:spPr>
-        <p:txBody>
-          <a:bodyPr wrap="square" lIns="0" rIns="0" tIns="0" bIns="0" anchor="ctr">
-            <a:noAutofit/>
-          </a:bodyPr>
-          <a:lstStyle/>
-          <a:p>
-            <a:pPr algn="ctr">
-              <a:spcBef>
-                <a:spcPts val="0"/>
-              </a:spcBef>
-              <a:spcAft>
-                <a:spcPts val="0"/>
-              </a:spcAft>
-            </a:pPr>
-            <a:r>
-              <a:rPr sz="750" b="1" i="0">
-                <a:solidFill>
-                  <a:srgbClr val="FFFFFF"/>
-                </a:solidFill>
-                <a:latin typeface="Calibri"/>
-              </a:rPr>
-              <a:t>SOURCE ACCOUNT</a:t>
-            </a:r>
-          </a:p>
-        </p:txBody>
-      </p:sp>
-      <p:sp>
-        <p:nvSpPr>
           <p:cNvPr id="10" name="Rounded Rectangle 9"/>
           <p:cNvSpPr/>
           <p:nvPr/>
@@ -32849,87 +32192,14 @@
       </p:sp>
       <p:sp>
         <p:nvSpPr>
-          <p:cNvPr id="31" name="Rounded Rectangle 30"/>
-          <p:cNvSpPr/>
-          <p:nvPr/>
-        </p:nvSpPr>
-        <p:spPr>
-          <a:xfrm>
-            <a:off x="868680" y="4133087"/>
-            <a:ext cx="1024128" cy="182880"/>
-          </a:xfrm>
-          <a:prstGeom prst="roundRect">
-            <a:avLst>
-              <a:gd name="adj" fmla="val 50000"/>
-            </a:avLst>
-          </a:prstGeom>
-          <a:solidFill>
-            <a:srgbClr val="1E2447"/>
-          </a:solidFill>
-          <a:ln>
-            <a:noFill/>
-          </a:ln>
-        </p:spPr>
-        <p:txBody>
-          <a:bodyPr rtlCol="0" anchor="ctr"/>
-          <a:lstStyle/>
-          <a:p>
-            <a:pPr algn="ctr"/>
-          </a:p>
-        </p:txBody>
-      </p:sp>
-      <p:sp>
-        <p:nvSpPr>
-          <p:cNvPr id="32" name="TextBox 31"/>
-          <p:cNvSpPr txBox="1"/>
-          <p:nvPr/>
-        </p:nvSpPr>
-        <p:spPr>
-          <a:xfrm>
-            <a:off x="868680" y="4133087"/>
-            <a:ext cx="1024128" cy="182880"/>
-          </a:xfrm>
-          <a:prstGeom prst="rect">
-            <a:avLst/>
-          </a:prstGeom>
-          <a:noFill/>
-        </p:spPr>
-        <p:txBody>
-          <a:bodyPr wrap="square" lIns="0" rIns="0" tIns="0" bIns="0" anchor="ctr">
-            <a:noAutofit/>
-          </a:bodyPr>
-          <a:lstStyle/>
-          <a:p>
-            <a:pPr algn="ctr">
-              <a:spcBef>
-                <a:spcPts val="0"/>
-              </a:spcBef>
-              <a:spcAft>
-                <a:spcPts val="0"/>
-              </a:spcAft>
-            </a:pPr>
-            <a:r>
-              <a:rPr sz="750" b="1" i="0">
-                <a:solidFill>
-                  <a:srgbClr val="FFFFFF"/>
-                </a:solidFill>
-                <a:latin typeface="Calibri"/>
-              </a:rPr>
-              <a:t>SOURCE ACCOUNT</a:t>
-            </a:r>
-          </a:p>
-        </p:txBody>
-      </p:sp>
-      <p:sp>
-        <p:nvSpPr>
           <p:cNvPr id="33" name="TextBox 32"/>
           <p:cNvSpPr txBox="1"/>
           <p:nvPr/>
         </p:nvSpPr>
         <p:spPr>
           <a:xfrm>
-            <a:off x="1984248" y="4096512"/>
-            <a:ext cx="2286000" cy="274320"/>
+            <a:off x="868680" y="4096512"/>
+            <a:ext cx="3383280" cy="274320"/>
           </a:xfrm>
           <a:prstGeom prst="rect">
             <a:avLst/>
@@ -32951,13 +32221,13 @@
               </a:spcAft>
             </a:pPr>
             <a:r>
-              <a:rPr sz="1050" b="0" i="0">
-                <a:solidFill>
-                  <a:srgbClr val="5A6377"/>
-                </a:solidFill>
-                <a:latin typeface="Calibri"/>
-              </a:rPr>
-              <a:t>what the primary texts teach</a:t>
+              <a:rPr sz="1050" b="0" i="1">
+                <a:solidFill>
+                  <a:srgbClr val="1E2447"/>
+                </a:solidFill>
+                <a:latin typeface="Calibri"/>
+              </a:rPr>
+              <a:t>Untagged content: what the primary texts teach</a:t>
             </a:r>
           </a:p>
         </p:txBody>
@@ -35394,79 +34664,6 @@
       </p:sp>
       <p:sp>
         <p:nvSpPr>
-          <p:cNvPr id="9" name="Rounded Rectangle 8"/>
-          <p:cNvSpPr/>
-          <p:nvPr/>
-        </p:nvSpPr>
-        <p:spPr>
-          <a:xfrm>
-            <a:off x="3328416" y="1188719"/>
-            <a:ext cx="1024128" cy="182880"/>
-          </a:xfrm>
-          <a:prstGeom prst="roundRect">
-            <a:avLst>
-              <a:gd name="adj" fmla="val 50000"/>
-            </a:avLst>
-          </a:prstGeom>
-          <a:solidFill>
-            <a:srgbClr val="1E2447"/>
-          </a:solidFill>
-          <a:ln>
-            <a:noFill/>
-          </a:ln>
-        </p:spPr>
-        <p:txBody>
-          <a:bodyPr rtlCol="0" anchor="ctr"/>
-          <a:lstStyle/>
-          <a:p>
-            <a:pPr algn="ctr"/>
-          </a:p>
-        </p:txBody>
-      </p:sp>
-      <p:sp>
-        <p:nvSpPr>
-          <p:cNvPr id="10" name="TextBox 9"/>
-          <p:cNvSpPr txBox="1"/>
-          <p:nvPr/>
-        </p:nvSpPr>
-        <p:spPr>
-          <a:xfrm>
-            <a:off x="3328416" y="1188719"/>
-            <a:ext cx="1024128" cy="182880"/>
-          </a:xfrm>
-          <a:prstGeom prst="rect">
-            <a:avLst/>
-          </a:prstGeom>
-          <a:noFill/>
-        </p:spPr>
-        <p:txBody>
-          <a:bodyPr wrap="square" lIns="0" rIns="0" tIns="0" bIns="0" anchor="ctr">
-            <a:noAutofit/>
-          </a:bodyPr>
-          <a:lstStyle/>
-          <a:p>
-            <a:pPr algn="ctr">
-              <a:spcBef>
-                <a:spcPts val="0"/>
-              </a:spcBef>
-              <a:spcAft>
-                <a:spcPts val="0"/>
-              </a:spcAft>
-            </a:pPr>
-            <a:r>
-              <a:rPr sz="750" b="1" i="0">
-                <a:solidFill>
-                  <a:srgbClr val="FFFFFF"/>
-                </a:solidFill>
-                <a:latin typeface="Calibri"/>
-              </a:rPr>
-              <a:t>SOURCE ACCOUNT</a:t>
-            </a:r>
-          </a:p>
-        </p:txBody>
-      </p:sp>
-      <p:sp>
-        <p:nvSpPr>
           <p:cNvPr id="11" name="TextBox 10"/>
           <p:cNvSpPr txBox="1"/>
           <p:nvPr/>
@@ -35613,79 +34810,6 @@
           <a:lstStyle/>
           <a:p>
             <a:pPr algn="ctr"/>
-          </a:p>
-        </p:txBody>
-      </p:sp>
-      <p:sp>
-        <p:nvSpPr>
-          <p:cNvPr id="14" name="Rounded Rectangle 13"/>
-          <p:cNvSpPr/>
-          <p:nvPr/>
-        </p:nvSpPr>
-        <p:spPr>
-          <a:xfrm>
-            <a:off x="3328416" y="2724912"/>
-            <a:ext cx="1024128" cy="182880"/>
-          </a:xfrm>
-          <a:prstGeom prst="roundRect">
-            <a:avLst>
-              <a:gd name="adj" fmla="val 50000"/>
-            </a:avLst>
-          </a:prstGeom>
-          <a:solidFill>
-            <a:srgbClr val="1E2447"/>
-          </a:solidFill>
-          <a:ln>
-            <a:noFill/>
-          </a:ln>
-        </p:spPr>
-        <p:txBody>
-          <a:bodyPr rtlCol="0" anchor="ctr"/>
-          <a:lstStyle/>
-          <a:p>
-            <a:pPr algn="ctr"/>
-          </a:p>
-        </p:txBody>
-      </p:sp>
-      <p:sp>
-        <p:nvSpPr>
-          <p:cNvPr id="15" name="TextBox 14"/>
-          <p:cNvSpPr txBox="1"/>
-          <p:nvPr/>
-        </p:nvSpPr>
-        <p:spPr>
-          <a:xfrm>
-            <a:off x="3328416" y="2724912"/>
-            <a:ext cx="1024128" cy="182880"/>
-          </a:xfrm>
-          <a:prstGeom prst="rect">
-            <a:avLst/>
-          </a:prstGeom>
-          <a:noFill/>
-        </p:spPr>
-        <p:txBody>
-          <a:bodyPr wrap="square" lIns="0" rIns="0" tIns="0" bIns="0" anchor="ctr">
-            <a:noAutofit/>
-          </a:bodyPr>
-          <a:lstStyle/>
-          <a:p>
-            <a:pPr algn="ctr">
-              <a:spcBef>
-                <a:spcPts val="0"/>
-              </a:spcBef>
-              <a:spcAft>
-                <a:spcPts val="0"/>
-              </a:spcAft>
-            </a:pPr>
-            <a:r>
-              <a:rPr sz="750" b="1" i="0">
-                <a:solidFill>
-                  <a:srgbClr val="FFFFFF"/>
-                </a:solidFill>
-                <a:latin typeface="Calibri"/>
-              </a:rPr>
-              <a:t>SOURCE ACCOUNT</a:t>
-            </a:r>
           </a:p>
         </p:txBody>
       </p:sp>
@@ -36482,18 +35606,18 @@
       </p:sp>
       <p:sp>
         <p:nvSpPr>
-          <p:cNvPr id="9" name="Rounded Rectangle 8"/>
+          <p:cNvPr id="11" name="Rounded Rectangle 10"/>
           <p:cNvSpPr/>
           <p:nvPr/>
         </p:nvSpPr>
         <p:spPr>
           <a:xfrm>
-            <a:off x="7351775" y="1188720"/>
-            <a:ext cx="1024128" cy="182880"/>
+            <a:off x="841248" y="1444752"/>
+            <a:ext cx="2286000" cy="566928"/>
           </a:xfrm>
           <a:prstGeom prst="roundRect">
             <a:avLst>
-              <a:gd name="adj" fmla="val 50000"/>
+              <a:gd name="adj" fmla="val 14000"/>
             </a:avLst>
           </a:prstGeom>
           <a:solidFill>
@@ -36513,14 +35637,14 @@
       </p:sp>
       <p:sp>
         <p:nvSpPr>
-          <p:cNvPr id="10" name="TextBox 9"/>
-          <p:cNvSpPr txBox="1"/>
-          <p:nvPr/>
-        </p:nvSpPr>
-        <p:spPr>
-          <a:xfrm>
-            <a:off x="7351775" y="1188720"/>
-            <a:ext cx="1024128" cy="182880"/>
+          <p:cNvPr id="12" name="TextBox 11"/>
+          <p:cNvSpPr txBox="1"/>
+          <p:nvPr/>
+        </p:nvSpPr>
+        <p:spPr>
+          <a:xfrm>
+            <a:off x="896112" y="1444752"/>
+            <a:ext cx="2176272" cy="566928"/>
           </a:xfrm>
           <a:prstGeom prst="rect">
             <a:avLst/>
@@ -36542,26 +35666,87 @@
               </a:spcAft>
             </a:pPr>
             <a:r>
-              <a:rPr sz="750" b="1" i="0">
+              <a:rPr sz="1400" b="1" i="0">
                 <a:solidFill>
                   <a:srgbClr val="FFFFFF"/>
                 </a:solidFill>
-                <a:latin typeface="Calibri"/>
-              </a:rPr>
-              <a:t>SOURCE ACCOUNT</a:t>
-            </a:r>
-          </a:p>
-        </p:txBody>
-      </p:sp>
-      <p:sp>
-        <p:nvSpPr>
-          <p:cNvPr id="11" name="Rounded Rectangle 10"/>
+                <a:latin typeface="Cambria"/>
+              </a:rPr>
+              <a:t>Sakshatkar</a:t>
+            </a:r>
+          </a:p>
+          <a:p>
+            <a:pPr algn="ctr">
+              <a:spcBef>
+                <a:spcPts val="0"/>
+              </a:spcBef>
+              <a:spcAft>
+                <a:spcPts val="0"/>
+              </a:spcAft>
+            </a:pPr>
+            <a:r>
+              <a:rPr sz="1000" b="0" i="1">
+                <a:solidFill>
+                  <a:srgbClr val="C9D4EF"/>
+                </a:solidFill>
+                <a:latin typeface="Calibri"/>
+              </a:rPr>
+              <a:t>Chitta</a:t>
+            </a:r>
+          </a:p>
+        </p:txBody>
+      </p:sp>
+      <p:sp>
+        <p:nvSpPr>
+          <p:cNvPr id="13" name="TextBox 12"/>
+          <p:cNvSpPr txBox="1"/>
+          <p:nvPr/>
+        </p:nvSpPr>
+        <p:spPr>
+          <a:xfrm>
+            <a:off x="841248" y="2084831"/>
+            <a:ext cx="2286000" cy="512064"/>
+          </a:xfrm>
+          <a:prstGeom prst="rect">
+            <a:avLst/>
+          </a:prstGeom>
+          <a:noFill/>
+        </p:spPr>
+        <p:txBody>
+          <a:bodyPr wrap="square" lIns="0" rIns="0" tIns="0" bIns="0" anchor="t">
+            <a:noAutofit/>
+          </a:bodyPr>
+          <a:lstStyle/>
+          <a:p>
+            <a:pPr algn="ctr">
+              <a:spcBef>
+                <a:spcPts val="0"/>
+              </a:spcBef>
+              <a:spcAft>
+                <a:spcPts val="0"/>
+              </a:spcAft>
+            </a:pPr>
+            <a:r>
+              <a:rPr sz="1150" b="0" i="0">
+                <a:solidFill>
+                  <a:srgbClr val="5A6377"/>
+                </a:solidFill>
+                <a:latin typeface="Calibri"/>
+              </a:rPr>
+              <a:t>Direct recognition of the reality being studied</a:t>
+            </a:r>
+          </a:p>
+        </p:txBody>
+      </p:sp>
+      <p:sp>
+        <p:nvSpPr>
+          <p:cNvPr id="14" name="Rounded Rectangle 13"/>
           <p:cNvSpPr/>
           <p:nvPr/>
         </p:nvSpPr>
         <p:spPr>
           <a:xfrm>
-            <a:off x="841248" y="1444752"/>
+            <a:off x="3419856" y="1444752"/>
             <a:ext cx="2286000" cy="566928"/>
           </a:xfrm>
           <a:prstGeom prst="roundRect">
@@ -36586,13 +35771,13 @@
       </p:sp>
       <p:sp>
         <p:nvSpPr>
-          <p:cNvPr id="12" name="TextBox 11"/>
-          <p:cNvSpPr txBox="1"/>
-          <p:nvPr/>
-        </p:nvSpPr>
-        <p:spPr>
-          <a:xfrm>
-            <a:off x="896112" y="1444752"/>
+          <p:cNvPr id="15" name="TextBox 14"/>
+          <p:cNvSpPr txBox="1"/>
+          <p:nvPr/>
+        </p:nvSpPr>
+        <p:spPr>
+          <a:xfrm>
+            <a:off x="3474720" y="1444752"/>
             <a:ext cx="2176272" cy="566928"/>
           </a:xfrm>
           <a:prstGeom prst="rect">
@@ -36621,7 +35806,7 @@
                 </a:solidFill>
                 <a:latin typeface="Cambria"/>
               </a:rPr>
-              <a:t>Sakshatkar</a:t>
+              <a:t>Bodh</a:t>
             </a:r>
           </a:p>
           <a:p>
@@ -36640,20 +35825,20 @@
                 </a:solidFill>
                 <a:latin typeface="Calibri"/>
               </a:rPr>
-              <a:t>Chitta</a:t>
-            </a:r>
-          </a:p>
-        </p:txBody>
-      </p:sp>
-      <p:sp>
-        <p:nvSpPr>
-          <p:cNvPr id="13" name="TextBox 12"/>
-          <p:cNvSpPr txBox="1"/>
-          <p:nvPr/>
-        </p:nvSpPr>
-        <p:spPr>
-          <a:xfrm>
-            <a:off x="841248" y="2084831"/>
+              <a:t>Buddhi</a:t>
+            </a:r>
+          </a:p>
+        </p:txBody>
+      </p:sp>
+      <p:sp>
+        <p:nvSpPr>
+          <p:cNvPr id="16" name="TextBox 15"/>
+          <p:cNvSpPr txBox="1"/>
+          <p:nvPr/>
+        </p:nvSpPr>
+        <p:spPr>
+          <a:xfrm>
+            <a:off x="3419856" y="2084831"/>
             <a:ext cx="2286000" cy="512064"/>
           </a:xfrm>
           <a:prstGeom prst="rect">
@@ -36682,20 +35867,20 @@
                 </a:solidFill>
                 <a:latin typeface="Calibri"/>
               </a:rPr>
-              <a:t>Direct recognition of the reality being studied</a:t>
-            </a:r>
-          </a:p>
-        </p:txBody>
-      </p:sp>
-      <p:sp>
-        <p:nvSpPr>
-          <p:cNvPr id="14" name="Rounded Rectangle 13"/>
+              <a:t>Definitive understanding, enlightenment</a:t>
+            </a:r>
+          </a:p>
+        </p:txBody>
+      </p:sp>
+      <p:sp>
+        <p:nvSpPr>
+          <p:cNvPr id="17" name="Rounded Rectangle 16"/>
           <p:cNvSpPr/>
           <p:nvPr/>
         </p:nvSpPr>
         <p:spPr>
           <a:xfrm>
-            <a:off x="3419856" y="1444752"/>
+            <a:off x="5998464" y="1444752"/>
             <a:ext cx="2286000" cy="566928"/>
           </a:xfrm>
           <a:prstGeom prst="roundRect">
@@ -36720,140 +35905,6 @@
       </p:sp>
       <p:sp>
         <p:nvSpPr>
-          <p:cNvPr id="15" name="TextBox 14"/>
-          <p:cNvSpPr txBox="1"/>
-          <p:nvPr/>
-        </p:nvSpPr>
-        <p:spPr>
-          <a:xfrm>
-            <a:off x="3474720" y="1444752"/>
-            <a:ext cx="2176272" cy="566928"/>
-          </a:xfrm>
-          <a:prstGeom prst="rect">
-            <a:avLst/>
-          </a:prstGeom>
-          <a:noFill/>
-        </p:spPr>
-        <p:txBody>
-          <a:bodyPr wrap="square" lIns="0" rIns="0" tIns="0" bIns="0" anchor="ctr">
-            <a:noAutofit/>
-          </a:bodyPr>
-          <a:lstStyle/>
-          <a:p>
-            <a:pPr algn="ctr">
-              <a:spcBef>
-                <a:spcPts val="0"/>
-              </a:spcBef>
-              <a:spcAft>
-                <a:spcPts val="0"/>
-              </a:spcAft>
-            </a:pPr>
-            <a:r>
-              <a:rPr sz="1400" b="1" i="0">
-                <a:solidFill>
-                  <a:srgbClr val="FFFFFF"/>
-                </a:solidFill>
-                <a:latin typeface="Cambria"/>
-              </a:rPr>
-              <a:t>Bodh</a:t>
-            </a:r>
-          </a:p>
-          <a:p>
-            <a:pPr algn="ctr">
-              <a:spcBef>
-                <a:spcPts val="0"/>
-              </a:spcBef>
-              <a:spcAft>
-                <a:spcPts val="0"/>
-              </a:spcAft>
-            </a:pPr>
-            <a:r>
-              <a:rPr sz="1000" b="0" i="1">
-                <a:solidFill>
-                  <a:srgbClr val="C9D4EF"/>
-                </a:solidFill>
-                <a:latin typeface="Calibri"/>
-              </a:rPr>
-              <a:t>Buddhi</a:t>
-            </a:r>
-          </a:p>
-        </p:txBody>
-      </p:sp>
-      <p:sp>
-        <p:nvSpPr>
-          <p:cNvPr id="16" name="TextBox 15"/>
-          <p:cNvSpPr txBox="1"/>
-          <p:nvPr/>
-        </p:nvSpPr>
-        <p:spPr>
-          <a:xfrm>
-            <a:off x="3419856" y="2084831"/>
-            <a:ext cx="2286000" cy="512064"/>
-          </a:xfrm>
-          <a:prstGeom prst="rect">
-            <a:avLst/>
-          </a:prstGeom>
-          <a:noFill/>
-        </p:spPr>
-        <p:txBody>
-          <a:bodyPr wrap="square" lIns="0" rIns="0" tIns="0" bIns="0" anchor="t">
-            <a:noAutofit/>
-          </a:bodyPr>
-          <a:lstStyle/>
-          <a:p>
-            <a:pPr algn="ctr">
-              <a:spcBef>
-                <a:spcPts val="0"/>
-              </a:spcBef>
-              <a:spcAft>
-                <a:spcPts val="0"/>
-              </a:spcAft>
-            </a:pPr>
-            <a:r>
-              <a:rPr sz="1150" b="0" i="0">
-                <a:solidFill>
-                  <a:srgbClr val="5A6377"/>
-                </a:solidFill>
-                <a:latin typeface="Calibri"/>
-              </a:rPr>
-              <a:t>Definitive understanding, enlightenment</a:t>
-            </a:r>
-          </a:p>
-        </p:txBody>
-      </p:sp>
-      <p:sp>
-        <p:nvSpPr>
-          <p:cNvPr id="17" name="Rounded Rectangle 16"/>
-          <p:cNvSpPr/>
-          <p:nvPr/>
-        </p:nvSpPr>
-        <p:spPr>
-          <a:xfrm>
-            <a:off x="5998464" y="1444752"/>
-            <a:ext cx="2286000" cy="566928"/>
-          </a:xfrm>
-          <a:prstGeom prst="roundRect">
-            <a:avLst>
-              <a:gd name="adj" fmla="val 14000"/>
-            </a:avLst>
-          </a:prstGeom>
-          <a:solidFill>
-            <a:srgbClr val="1E2447"/>
-          </a:solidFill>
-          <a:ln>
-            <a:noFill/>
-          </a:ln>
-        </p:spPr>
-        <p:txBody>
-          <a:bodyPr rtlCol="0" anchor="ctr"/>
-          <a:lstStyle/>
-          <a:p>
-            <a:pPr algn="ctr"/>
-          </a:p>
-        </p:txBody>
-      </p:sp>
-      <p:sp>
-        <p:nvSpPr>
           <p:cNvPr id="18" name="TextBox 17"/>
           <p:cNvSpPr txBox="1"/>
           <p:nvPr/>
@@ -37249,79 +36300,6 @@
           <a:lstStyle/>
           <a:p>
             <a:pPr algn="ctr"/>
-          </a:p>
-        </p:txBody>
-      </p:sp>
-      <p:sp>
-        <p:nvSpPr>
-          <p:cNvPr id="27" name="Rounded Rectangle 26"/>
-          <p:cNvSpPr/>
-          <p:nvPr/>
-        </p:nvSpPr>
-        <p:spPr>
-          <a:xfrm>
-            <a:off x="7351775" y="3017520"/>
-            <a:ext cx="1024128" cy="182880"/>
-          </a:xfrm>
-          <a:prstGeom prst="roundRect">
-            <a:avLst>
-              <a:gd name="adj" fmla="val 50000"/>
-            </a:avLst>
-          </a:prstGeom>
-          <a:solidFill>
-            <a:srgbClr val="1E2447"/>
-          </a:solidFill>
-          <a:ln>
-            <a:noFill/>
-          </a:ln>
-        </p:spPr>
-        <p:txBody>
-          <a:bodyPr rtlCol="0" anchor="ctr"/>
-          <a:lstStyle/>
-          <a:p>
-            <a:pPr algn="ctr"/>
-          </a:p>
-        </p:txBody>
-      </p:sp>
-      <p:sp>
-        <p:nvSpPr>
-          <p:cNvPr id="28" name="TextBox 27"/>
-          <p:cNvSpPr txBox="1"/>
-          <p:nvPr/>
-        </p:nvSpPr>
-        <p:spPr>
-          <a:xfrm>
-            <a:off x="7351775" y="3017520"/>
-            <a:ext cx="1024128" cy="182880"/>
-          </a:xfrm>
-          <a:prstGeom prst="rect">
-            <a:avLst/>
-          </a:prstGeom>
-          <a:noFill/>
-        </p:spPr>
-        <p:txBody>
-          <a:bodyPr wrap="square" lIns="0" rIns="0" tIns="0" bIns="0" anchor="ctr">
-            <a:noAutofit/>
-          </a:bodyPr>
-          <a:lstStyle/>
-          <a:p>
-            <a:pPr algn="ctr">
-              <a:spcBef>
-                <a:spcPts val="0"/>
-              </a:spcBef>
-              <a:spcAft>
-                <a:spcPts val="0"/>
-              </a:spcAft>
-            </a:pPr>
-            <a:r>
-              <a:rPr sz="750" b="1" i="0">
-                <a:solidFill>
-                  <a:srgbClr val="FFFFFF"/>
-                </a:solidFill>
-                <a:latin typeface="Calibri"/>
-              </a:rPr>
-              <a:t>SOURCE ACCOUNT</a:t>
-            </a:r>
           </a:p>
         </p:txBody>
       </p:sp>
@@ -38162,79 +37140,6 @@
       </p:sp>
       <p:sp>
         <p:nvSpPr>
-          <p:cNvPr id="21" name="Rounded Rectangle 20"/>
-          <p:cNvSpPr/>
-          <p:nvPr/>
-        </p:nvSpPr>
-        <p:spPr>
-          <a:xfrm>
-            <a:off x="7351775" y="1188719"/>
-            <a:ext cx="1024128" cy="182880"/>
-          </a:xfrm>
-          <a:prstGeom prst="roundRect">
-            <a:avLst>
-              <a:gd name="adj" fmla="val 50000"/>
-            </a:avLst>
-          </a:prstGeom>
-          <a:solidFill>
-            <a:srgbClr val="1E2447"/>
-          </a:solidFill>
-          <a:ln>
-            <a:noFill/>
-          </a:ln>
-        </p:spPr>
-        <p:txBody>
-          <a:bodyPr rtlCol="0" anchor="ctr"/>
-          <a:lstStyle/>
-          <a:p>
-            <a:pPr algn="ctr"/>
-          </a:p>
-        </p:txBody>
-      </p:sp>
-      <p:sp>
-        <p:nvSpPr>
-          <p:cNvPr id="22" name="TextBox 21"/>
-          <p:cNvSpPr txBox="1"/>
-          <p:nvPr/>
-        </p:nvSpPr>
-        <p:spPr>
-          <a:xfrm>
-            <a:off x="7351775" y="1188719"/>
-            <a:ext cx="1024128" cy="182880"/>
-          </a:xfrm>
-          <a:prstGeom prst="rect">
-            <a:avLst/>
-          </a:prstGeom>
-          <a:noFill/>
-        </p:spPr>
-        <p:txBody>
-          <a:bodyPr wrap="square" lIns="0" rIns="0" tIns="0" bIns="0" anchor="ctr">
-            <a:noAutofit/>
-          </a:bodyPr>
-          <a:lstStyle/>
-          <a:p>
-            <a:pPr algn="ctr">
-              <a:spcBef>
-                <a:spcPts val="0"/>
-              </a:spcBef>
-              <a:spcAft>
-                <a:spcPts val="0"/>
-              </a:spcAft>
-            </a:pPr>
-            <a:r>
-              <a:rPr sz="750" b="1" i="0">
-                <a:solidFill>
-                  <a:srgbClr val="FFFFFF"/>
-                </a:solidFill>
-                <a:latin typeface="Calibri"/>
-              </a:rPr>
-              <a:t>SOURCE ACCOUNT</a:t>
-            </a:r>
-          </a:p>
-        </p:txBody>
-      </p:sp>
-      <p:sp>
-        <p:nvSpPr>
           <p:cNvPr id="23" name="TextBox 22"/>
           <p:cNvSpPr txBox="1"/>
           <p:nvPr/>
@@ -40275,79 +39180,6 @@
       </p:sp>
       <p:sp>
         <p:nvSpPr>
-          <p:cNvPr id="10" name="Rounded Rectangle 9"/>
-          <p:cNvSpPr/>
-          <p:nvPr/>
-        </p:nvSpPr>
-        <p:spPr>
-          <a:xfrm>
-            <a:off x="2002536" y="1783079"/>
-            <a:ext cx="1024128" cy="182880"/>
-          </a:xfrm>
-          <a:prstGeom prst="roundRect">
-            <a:avLst>
-              <a:gd name="adj" fmla="val 50000"/>
-            </a:avLst>
-          </a:prstGeom>
-          <a:solidFill>
-            <a:srgbClr val="1E2447"/>
-          </a:solidFill>
-          <a:ln>
-            <a:noFill/>
-          </a:ln>
-        </p:spPr>
-        <p:txBody>
-          <a:bodyPr rtlCol="0" anchor="ctr"/>
-          <a:lstStyle/>
-          <a:p>
-            <a:pPr algn="ctr"/>
-          </a:p>
-        </p:txBody>
-      </p:sp>
-      <p:sp>
-        <p:nvSpPr>
-          <p:cNvPr id="11" name="TextBox 10"/>
-          <p:cNvSpPr txBox="1"/>
-          <p:nvPr/>
-        </p:nvSpPr>
-        <p:spPr>
-          <a:xfrm>
-            <a:off x="2002536" y="1783079"/>
-            <a:ext cx="1024128" cy="182880"/>
-          </a:xfrm>
-          <a:prstGeom prst="rect">
-            <a:avLst/>
-          </a:prstGeom>
-          <a:noFill/>
-        </p:spPr>
-        <p:txBody>
-          <a:bodyPr wrap="square" lIns="0" rIns="0" tIns="0" bIns="0" anchor="ctr">
-            <a:noAutofit/>
-          </a:bodyPr>
-          <a:lstStyle/>
-          <a:p>
-            <a:pPr algn="ctr">
-              <a:spcBef>
-                <a:spcPts val="0"/>
-              </a:spcBef>
-              <a:spcAft>
-                <a:spcPts val="0"/>
-              </a:spcAft>
-            </a:pPr>
-            <a:r>
-              <a:rPr sz="750" b="1" i="0">
-                <a:solidFill>
-                  <a:srgbClr val="FFFFFF"/>
-                </a:solidFill>
-                <a:latin typeface="Calibri"/>
-              </a:rPr>
-              <a:t>SOURCE ACCOUNT</a:t>
-            </a:r>
-          </a:p>
-        </p:txBody>
-      </p:sp>
-      <p:sp>
-        <p:nvSpPr>
           <p:cNvPr id="12" name="TextBox 11"/>
           <p:cNvSpPr txBox="1"/>
           <p:nvPr/>
@@ -40664,79 +39496,6 @@
           <a:lstStyle/>
           <a:p>
             <a:pPr algn="ctr"/>
-          </a:p>
-        </p:txBody>
-      </p:sp>
-      <p:sp>
-        <p:nvSpPr>
-          <p:cNvPr id="20" name="Rounded Rectangle 19"/>
-          <p:cNvSpPr/>
-          <p:nvPr/>
-        </p:nvSpPr>
-        <p:spPr>
-          <a:xfrm>
-            <a:off x="7351775" y="1783079"/>
-            <a:ext cx="1024128" cy="182880"/>
-          </a:xfrm>
-          <a:prstGeom prst="roundRect">
-            <a:avLst>
-              <a:gd name="adj" fmla="val 50000"/>
-            </a:avLst>
-          </a:prstGeom>
-          <a:solidFill>
-            <a:srgbClr val="1E2447"/>
-          </a:solidFill>
-          <a:ln>
-            <a:noFill/>
-          </a:ln>
-        </p:spPr>
-        <p:txBody>
-          <a:bodyPr rtlCol="0" anchor="ctr"/>
-          <a:lstStyle/>
-          <a:p>
-            <a:pPr algn="ctr"/>
-          </a:p>
-        </p:txBody>
-      </p:sp>
-      <p:sp>
-        <p:nvSpPr>
-          <p:cNvPr id="21" name="TextBox 20"/>
-          <p:cNvSpPr txBox="1"/>
-          <p:nvPr/>
-        </p:nvSpPr>
-        <p:spPr>
-          <a:xfrm>
-            <a:off x="7351775" y="1783079"/>
-            <a:ext cx="1024128" cy="182880"/>
-          </a:xfrm>
-          <a:prstGeom prst="rect">
-            <a:avLst/>
-          </a:prstGeom>
-          <a:noFill/>
-        </p:spPr>
-        <p:txBody>
-          <a:bodyPr wrap="square" lIns="0" rIns="0" tIns="0" bIns="0" anchor="ctr">
-            <a:noAutofit/>
-          </a:bodyPr>
-          <a:lstStyle/>
-          <a:p>
-            <a:pPr algn="ctr">
-              <a:spcBef>
-                <a:spcPts val="0"/>
-              </a:spcBef>
-              <a:spcAft>
-                <a:spcPts val="0"/>
-              </a:spcAft>
-            </a:pPr>
-            <a:r>
-              <a:rPr sz="750" b="1" i="0">
-                <a:solidFill>
-                  <a:srgbClr val="FFFFFF"/>
-                </a:solidFill>
-                <a:latin typeface="Calibri"/>
-              </a:rPr>
-              <a:t>SOURCE ACCOUNT</a:t>
-            </a:r>
           </a:p>
         </p:txBody>
       </p:sp>
@@ -42379,79 +41138,6 @@
           <a:lstStyle/>
           <a:p>
             <a:pPr algn="ctr"/>
-          </a:p>
-        </p:txBody>
-      </p:sp>
-      <p:sp>
-        <p:nvSpPr>
-          <p:cNvPr id="41" name="Rounded Rectangle 40"/>
-          <p:cNvSpPr/>
-          <p:nvPr/>
-        </p:nvSpPr>
-        <p:spPr>
-          <a:xfrm>
-            <a:off x="7351775" y="1207008"/>
-            <a:ext cx="1024128" cy="182880"/>
-          </a:xfrm>
-          <a:prstGeom prst="roundRect">
-            <a:avLst>
-              <a:gd name="adj" fmla="val 50000"/>
-            </a:avLst>
-          </a:prstGeom>
-          <a:solidFill>
-            <a:srgbClr val="1E2447"/>
-          </a:solidFill>
-          <a:ln>
-            <a:noFill/>
-          </a:ln>
-        </p:spPr>
-        <p:txBody>
-          <a:bodyPr rtlCol="0" anchor="ctr"/>
-          <a:lstStyle/>
-          <a:p>
-            <a:pPr algn="ctr"/>
-          </a:p>
-        </p:txBody>
-      </p:sp>
-      <p:sp>
-        <p:nvSpPr>
-          <p:cNvPr id="42" name="TextBox 41"/>
-          <p:cNvSpPr txBox="1"/>
-          <p:nvPr/>
-        </p:nvSpPr>
-        <p:spPr>
-          <a:xfrm>
-            <a:off x="7351775" y="1207008"/>
-            <a:ext cx="1024128" cy="182880"/>
-          </a:xfrm>
-          <a:prstGeom prst="rect">
-            <a:avLst/>
-          </a:prstGeom>
-          <a:noFill/>
-        </p:spPr>
-        <p:txBody>
-          <a:bodyPr wrap="square" lIns="0" rIns="0" tIns="0" bIns="0" anchor="ctr">
-            <a:noAutofit/>
-          </a:bodyPr>
-          <a:lstStyle/>
-          <a:p>
-            <a:pPr algn="ctr">
-              <a:spcBef>
-                <a:spcPts val="0"/>
-              </a:spcBef>
-              <a:spcAft>
-                <a:spcPts val="0"/>
-              </a:spcAft>
-            </a:pPr>
-            <a:r>
-              <a:rPr sz="750" b="1" i="0">
-                <a:solidFill>
-                  <a:srgbClr val="FFFFFF"/>
-                </a:solidFill>
-                <a:latin typeface="Calibri"/>
-              </a:rPr>
-              <a:t>SOURCE ACCOUNT</a:t>
-            </a:r>
           </a:p>
         </p:txBody>
       </p:sp>

</xml_diff>